<commit_message>
Deck + run sheet: add live URL/repo/contact, Google Cloud stack line, accountability
Deck: live URL on title + close slides, GitHub repo and email on close,
'Built on Google Cloud' stack strip (Gemini 2.5 Pro+Flash, Cloud Run,
roadmap Firestore/BigQuery) on the deployability slide, relabel the
outbreak stat as peak-centre 16.6 sigma, add a reporting-compliance
bullet to the district side.

Run sheet: new blind-spots walkthrough step, reporter capture in the
centrepiece, report-the-blind-spot-and-watch-it-clear as the live-proof
move, and a Q&A answer for 'what if a centre doesn't report'.
</commit_message>
<xml_diff>
--- a/pitch/Arogya-Radar-Pitch.pptx
+++ b/pitch/Arogya-Radar-Pitch.pptx
@@ -2802,8 +2802,8 @@
         </p:nvSpPr>
         <p:spPr>
           <a:xfrm>
-            <a:off x="594360" y="5440680"/>
-            <a:ext cx="8229600" cy="320040"/>
+            <a:off x="594360" y="5394960"/>
+            <a:ext cx="8229600" cy="292608"/>
           </a:xfrm>
           <a:prstGeom prst="rect">
             <a:avLst/>
@@ -2828,6 +2828,59 @@
                 <a:cs typeface="Calibri" pitchFamily="34" charset="-120"/>
               </a:rPr>
               <a:t>Mann Sutaria</a:t>
+            </a:r>
+            <a:endParaRPr lang="en-US" sz="1300" dirty="0"/>
+          </a:p>
+        </p:txBody>
+      </p:sp>
+      <p:sp>
+        <p:nvSpPr>
+          <p:cNvPr id="14" name="Text 12"/>
+          <p:cNvSpPr/>
+          <p:nvPr/>
+        </p:nvSpPr>
+        <p:spPr>
+          <a:xfrm>
+            <a:off x="594360" y="5742432"/>
+            <a:ext cx="8686800" cy="292608"/>
+          </a:xfrm>
+          <a:prstGeom prst="rect">
+            <a:avLst/>
+          </a:prstGeom>
+          <a:noFill/>
+          <a:ln/>
+        </p:spPr>
+        <p:txBody>
+          <a:bodyPr wrap="square" lIns="0" tIns="0" rIns="0" bIns="0" rtlCol="0" anchor="ctr"/>
+          <a:lstStyle/>
+          <a:p>
+            <a:pPr indent="0" marL="0">
+              <a:buNone/>
+            </a:pPr>
+            <a:r>
+              <a:rPr lang="en-US" sz="1300" dirty="0">
+                <a:solidFill>
+                  <a:srgbClr val="5EEAD4"/>
+                </a:solidFill>
+                <a:latin typeface="Calibri" pitchFamily="34" charset="0"/>
+                <a:ea typeface="Calibri" pitchFamily="34" charset="-122"/>
+                <a:cs typeface="Calibri" pitchFamily="34" charset="-120"/>
+              </a:rPr>
+              <a:t>Live on Google Cloud:  </a:t>
+            </a:r>
+            <a:pPr indent="0" marL="0">
+              <a:buNone/>
+            </a:pPr>
+            <a:r>
+              <a:rPr lang="en-US" sz="1300" dirty="0">
+                <a:solidFill>
+                  <a:srgbClr val="CFE3EC"/>
+                </a:solidFill>
+                <a:latin typeface="Calibri" pitchFamily="34" charset="0"/>
+                <a:ea typeface="Calibri" pitchFamily="34" charset="-122"/>
+                <a:cs typeface="Calibri" pitchFamily="34" charset="-120"/>
+              </a:rPr>
+              <a:t>arogya-radar-767054106508.asia-south1.run.app</a:t>
             </a:r>
             <a:endParaRPr lang="en-US" sz="1300" dirty="0"/>
           </a:p>
@@ -3565,7 +3618,82 @@
       </p:sp>
       <p:sp>
         <p:nvSpPr>
-          <p:cNvPr id="24" name="Text 22"/>
+          <p:cNvPr id="24" name="Shape 22"/>
+          <p:cNvSpPr/>
+          <p:nvPr/>
+        </p:nvSpPr>
+        <p:spPr>
+          <a:xfrm>
+            <a:off x="594360" y="5943600"/>
+            <a:ext cx="11000232" cy="502920"/>
+          </a:xfrm>
+          <a:prstGeom prst="roundRect">
+            <a:avLst>
+              <a:gd name="adj" fmla="val 10909"/>
+            </a:avLst>
+          </a:prstGeom>
+          <a:solidFill>
+            <a:srgbClr val="0E2430"/>
+          </a:solidFill>
+          <a:ln/>
+        </p:spPr>
+      </p:sp>
+      <p:sp>
+        <p:nvSpPr>
+          <p:cNvPr id="25" name="Text 23"/>
+          <p:cNvSpPr/>
+          <p:nvPr/>
+        </p:nvSpPr>
+        <p:spPr>
+          <a:xfrm>
+            <a:off x="914400" y="5943600"/>
+            <a:ext cx="10360152" cy="502920"/>
+          </a:xfrm>
+          <a:prstGeom prst="rect">
+            <a:avLst/>
+          </a:prstGeom>
+          <a:noFill/>
+          <a:ln/>
+        </p:spPr>
+        <p:txBody>
+          <a:bodyPr wrap="square" lIns="0" tIns="0" rIns="0" bIns="0" rtlCol="0" anchor="ctr"/>
+          <a:lstStyle/>
+          <a:p>
+            <a:pPr algn="ctr" indent="0" marL="0">
+              <a:buNone/>
+            </a:pPr>
+            <a:r>
+              <a:rPr lang="en-US" sz="1300" b="1" dirty="0">
+                <a:solidFill>
+                  <a:srgbClr val="5EEAD4"/>
+                </a:solidFill>
+                <a:latin typeface="Calibri" pitchFamily="34" charset="0"/>
+                <a:ea typeface="Calibri" pitchFamily="34" charset="-122"/>
+                <a:cs typeface="Calibri" pitchFamily="34" charset="-120"/>
+              </a:rPr>
+              <a:t>Built on Google Cloud:  </a:t>
+            </a:r>
+            <a:pPr algn="ctr" indent="0" marL="0">
+              <a:buNone/>
+            </a:pPr>
+            <a:r>
+              <a:rPr lang="en-US" sz="1300" dirty="0">
+                <a:solidFill>
+                  <a:srgbClr val="E4F1F5"/>
+                </a:solidFill>
+                <a:latin typeface="Calibri" pitchFamily="34" charset="0"/>
+                <a:ea typeface="Calibri" pitchFamily="34" charset="-122"/>
+                <a:cs typeface="Calibri" pitchFamily="34" charset="-120"/>
+              </a:rPr>
+              <a:t>Gemini 2.5 (Pro for intake, Flash for briefs) · Cloud Run · roadmap: Firestore, BigQuery</a:t>
+            </a:r>
+            <a:endParaRPr lang="en-US" sz="1300" dirty="0"/>
+          </a:p>
+        </p:txBody>
+      </p:sp>
+      <p:sp>
+        <p:nvSpPr>
+          <p:cNvPr id="26" name="Text 24"/>
           <p:cNvSpPr/>
           <p:nvPr/>
         </p:nvSpPr>
@@ -3604,7 +3732,7 @@
       </p:sp>
       <p:sp>
         <p:nvSpPr>
-          <p:cNvPr id="25" name="Text 23"/>
+          <p:cNvPr id="27" name="Text 25"/>
           <p:cNvSpPr/>
           <p:nvPr/>
         </p:nvSpPr>
@@ -3643,7 +3771,7 @@
       </p:sp>
       <p:sp>
         <p:nvSpPr>
-          <p:cNvPr id="26" name="Text 24"/>
+          <p:cNvPr id="28" name="Text 26"/>
           <p:cNvSpPr/>
           <p:nvPr/>
         </p:nvSpPr>
@@ -5120,7 +5248,7 @@
         </p:nvSpPr>
         <p:spPr>
           <a:xfrm>
-            <a:off x="594360" y="5257800"/>
+            <a:off x="594360" y="5120640"/>
             <a:ext cx="7498080" cy="0"/>
           </a:xfrm>
           <a:prstGeom prst="line">
@@ -5143,8 +5271,8 @@
         </p:nvSpPr>
         <p:spPr>
           <a:xfrm>
-            <a:off x="594360" y="5394960"/>
-            <a:ext cx="8503920" cy="457200"/>
+            <a:off x="594360" y="5230368"/>
+            <a:ext cx="8503920" cy="320040"/>
           </a:xfrm>
           <a:prstGeom prst="rect">
             <a:avLst/>
@@ -5182,7 +5310,7 @@
                 <a:ea typeface="Calibri" pitchFamily="34" charset="-122"/>
                 <a:cs typeface="Calibri" pitchFamily="34" charset="-120"/>
               </a:rPr>
-              <a:t>Firestore persistence · WhatsApp intake channel · BigQuery cross-district · IDSP / e-Aushadhi export</a:t>
+              <a:t>Firestore · WhatsApp intake · BigQuery cross-district · IDSP / e-Aushadhi export</a:t>
             </a:r>
             <a:endParaRPr lang="en-US" sz="1250" dirty="0"/>
           </a:p>
@@ -5196,8 +5324,8 @@
         </p:nvSpPr>
         <p:spPr>
           <a:xfrm>
-            <a:off x="594360" y="5943600"/>
-            <a:ext cx="8229600" cy="365760"/>
+            <a:off x="594360" y="5596128"/>
+            <a:ext cx="10972800" cy="320040"/>
           </a:xfrm>
           <a:prstGeom prst="rect">
             <a:avLst/>
@@ -5213,23 +5341,118 @@
               <a:buNone/>
             </a:pPr>
             <a:r>
-              <a:rPr lang="en-US" sz="1600" b="1" i="1" dirty="0">
+              <a:rPr lang="en-US" sz="1200" b="1" dirty="0">
+                <a:solidFill>
+                  <a:srgbClr val="5EEAD4"/>
+                </a:solidFill>
+                <a:latin typeface="Calibri" pitchFamily="34" charset="0"/>
+                <a:ea typeface="Calibri" pitchFamily="34" charset="-122"/>
+                <a:cs typeface="Calibri" pitchFamily="34" charset="-120"/>
+              </a:rPr>
+              <a:t>Live:  </a:t>
+            </a:r>
+            <a:pPr indent="0" marL="0">
+              <a:buNone/>
+            </a:pPr>
+            <a:r>
+              <a:rPr lang="en-US" sz="1200" dirty="0">
+                <a:solidFill>
+                  <a:srgbClr val="CFE3EC"/>
+                </a:solidFill>
+                <a:latin typeface="Calibri" pitchFamily="34" charset="0"/>
+                <a:ea typeface="Calibri" pitchFamily="34" charset="-122"/>
+                <a:cs typeface="Calibri" pitchFamily="34" charset="-120"/>
+              </a:rPr>
+              <a:t>arogya-radar-767054106508.asia-south1.run.app</a:t>
+            </a:r>
+            <a:pPr indent="0" marL="0">
+              <a:buNone/>
+            </a:pPr>
+            <a:r>
+              <a:rPr lang="en-US" sz="1200" b="1" dirty="0">
+                <a:solidFill>
+                  <a:srgbClr val="5EEAD4"/>
+                </a:solidFill>
+                <a:latin typeface="Calibri" pitchFamily="34" charset="0"/>
+                <a:ea typeface="Calibri" pitchFamily="34" charset="-122"/>
+                <a:cs typeface="Calibri" pitchFamily="34" charset="-120"/>
+              </a:rPr>
+              <a:t>     Repo:  </a:t>
+            </a:r>
+            <a:pPr indent="0" marL="0">
+              <a:buNone/>
+            </a:pPr>
+            <a:r>
+              <a:rPr lang="en-US" sz="1200" dirty="0">
+                <a:solidFill>
+                  <a:srgbClr val="CFE3EC"/>
+                </a:solidFill>
+                <a:latin typeface="Calibri" pitchFamily="34" charset="0"/>
+                <a:ea typeface="Calibri" pitchFamily="34" charset="-122"/>
+                <a:cs typeface="Calibri" pitchFamily="34" charset="-120"/>
+              </a:rPr>
+              <a:t>github.com/PureGenius369/arogya-radar</a:t>
+            </a:r>
+            <a:endParaRPr lang="en-US" sz="1200" dirty="0"/>
+          </a:p>
+        </p:txBody>
+      </p:sp>
+      <p:sp>
+        <p:nvSpPr>
+          <p:cNvPr id="21" name="Text 19"/>
+          <p:cNvSpPr/>
+          <p:nvPr/>
+        </p:nvSpPr>
+        <p:spPr>
+          <a:xfrm>
+            <a:off x="594360" y="5980176"/>
+            <a:ext cx="10972800" cy="365760"/>
+          </a:xfrm>
+          <a:prstGeom prst="rect">
+            <a:avLst/>
+          </a:prstGeom>
+          <a:noFill/>
+          <a:ln/>
+        </p:spPr>
+        <p:txBody>
+          <a:bodyPr wrap="square" lIns="0" tIns="0" rIns="0" bIns="0" rtlCol="0" anchor="ctr"/>
+          <a:lstStyle/>
+          <a:p>
+            <a:pPr indent="0" marL="0">
+              <a:buNone/>
+            </a:pPr>
+            <a:r>
+              <a:rPr lang="en-US" sz="1300" dirty="0">
+                <a:solidFill>
+                  <a:srgbClr val="9DB8C4"/>
+                </a:solidFill>
+                <a:latin typeface="Calibri" pitchFamily="34" charset="0"/>
+                <a:ea typeface="Calibri" pitchFamily="34" charset="-122"/>
+                <a:cs typeface="Calibri" pitchFamily="34" charset="-120"/>
+              </a:rPr>
+              <a:t>Mann Sutaria · mannsutaria2605@gmail.com     </a:t>
+            </a:r>
+            <a:pPr indent="0" marL="0">
+              <a:buNone/>
+            </a:pPr>
+            <a:r>
+              <a:rPr lang="en-US" sz="1300" b="1" i="1" dirty="0">
                 <a:solidFill>
                   <a:srgbClr val="FFFFFF"/>
                 </a:solidFill>
-                <a:latin typeface="Cambria" pitchFamily="34" charset="0"/>
-                <a:ea typeface="Cambria" pitchFamily="34" charset="-122"/>
-                <a:cs typeface="Cambria" pitchFamily="34" charset="-120"/>
-              </a:rPr>
-              <a:t>Arogya Radar  ·  the district's registers, finally read.</a:t>
-            </a:r>
-            <a:endParaRPr lang="en-US" sz="1600" dirty="0"/>
-          </a:p>
-        </p:txBody>
-      </p:sp>
-      <p:sp>
-        <p:nvSpPr>
-          <p:cNvPr id="21" name="Text 19"/>
+                <a:latin typeface="Calibri" pitchFamily="34" charset="0"/>
+                <a:ea typeface="Calibri" pitchFamily="34" charset="-122"/>
+                <a:cs typeface="Calibri" pitchFamily="34" charset="-120"/>
+              </a:rPr>
+              <a:t>Arogya Radar — the district's registers, finally read.</a:t>
+            </a:r>
+            <a:endParaRPr lang="en-US" sz="1300" dirty="0"/>
+          </a:p>
+        </p:txBody>
+      </p:sp>
+      <p:sp>
+        <p:nvSpPr>
+          <p:cNvPr id="22" name="Text 20"/>
           <p:cNvSpPr/>
           <p:nvPr/>
         </p:nvSpPr>
@@ -5268,7 +5491,7 @@
       </p:sp>
       <p:sp>
         <p:nvSpPr>
-          <p:cNvPr id="22" name="Text 20"/>
+          <p:cNvPr id="23" name="Text 21"/>
           <p:cNvSpPr/>
           <p:nvPr/>
         </p:nvSpPr>
@@ -5307,7 +5530,7 @@
       </p:sp>
       <p:sp>
         <p:nvSpPr>
-          <p:cNvPr id="23" name="Text 21"/>
+          <p:cNvPr id="24" name="Text 22"/>
           <p:cNvSpPr/>
           <p:nvPr/>
         </p:nvSpPr>
@@ -6996,8 +7219,8 @@
         </p:nvSpPr>
         <p:spPr>
           <a:xfrm>
-            <a:off x="6871716" y="2926080"/>
-            <a:ext cx="4357116" cy="2651760"/>
+            <a:off x="6871716" y="2880360"/>
+            <a:ext cx="4357116" cy="2743200"/>
           </a:xfrm>
           <a:prstGeom prst="rect">
             <a:avLst/>
@@ -7011,16 +7234,16 @@
           <a:p>
             <a:pPr marL="342900" indent="-342900">
               <a:lnSpc>
-                <a:spcPct val="105000"/>
+                <a:spcPct val="103000"/>
               </a:lnSpc>
               <a:spcAft>
-                <a:spcPts val="1100"/>
+                <a:spcPts val="800"/>
               </a:spcAft>
               <a:buSzPct val="100000"/>
               <a:buChar char="•"/>
             </a:pPr>
             <a:r>
-              <a:rPr lang="en-US" sz="1450" dirty="0">
+              <a:rPr lang="en-US" sz="1350" dirty="0">
                 <a:solidFill>
                   <a:srgbClr val="E4F1F5"/>
                 </a:solidFill>
@@ -7030,21 +7253,21 @@
               </a:rPr>
               <a:t>Outbreak radar — early warning across the district</a:t>
             </a:r>
-            <a:endParaRPr lang="en-US" sz="1450" dirty="0"/>
+            <a:endParaRPr lang="en-US" sz="1350" dirty="0"/>
           </a:p>
           <a:p>
             <a:pPr marL="342900" indent="-342900">
               <a:lnSpc>
-                <a:spcPct val="105000"/>
+                <a:spcPct val="103000"/>
               </a:lnSpc>
               <a:spcAft>
-                <a:spcPts val="1100"/>
+                <a:spcPts val="800"/>
               </a:spcAft>
               <a:buSzPct val="100000"/>
               <a:buChar char="•"/>
             </a:pPr>
             <a:r>
-              <a:rPr lang="en-US" sz="1450" dirty="0">
+              <a:rPr lang="en-US" sz="1350" dirty="0">
                 <a:solidFill>
                   <a:srgbClr val="E4F1F5"/>
                 </a:solidFill>
@@ -7052,23 +7275,23 @@
                 <a:ea typeface="Calibri" pitchFamily="34" charset="-122"/>
                 <a:cs typeface="Calibri" pitchFamily="34" charset="-120"/>
               </a:rPr>
-              <a:t>Stock forecasts — who runs out of what, and when</a:t>
-            </a:r>
-            <a:endParaRPr lang="en-US" sz="1450" dirty="0"/>
+              <a:t>Reporting compliance — silent centres flagged as blind spots</a:t>
+            </a:r>
+            <a:endParaRPr lang="en-US" sz="1350" dirty="0"/>
           </a:p>
           <a:p>
             <a:pPr marL="342900" indent="-342900">
               <a:lnSpc>
-                <a:spcPct val="105000"/>
+                <a:spcPct val="103000"/>
               </a:lnSpc>
               <a:spcAft>
-                <a:spcPts val="1100"/>
+                <a:spcPts val="800"/>
               </a:spcAft>
               <a:buSzPct val="100000"/>
               <a:buChar char="•"/>
             </a:pPr>
             <a:r>
-              <a:rPr lang="en-US" sz="1450" dirty="0">
+              <a:rPr lang="en-US" sz="1350" dirty="0">
                 <a:solidFill>
                   <a:srgbClr val="E4F1F5"/>
                 </a:solidFill>
@@ -7076,23 +7299,23 @@
                 <a:ea typeface="Calibri" pitchFamily="34" charset="-122"/>
                 <a:cs typeface="Calibri" pitchFamily="34" charset="-120"/>
               </a:rPr>
-              <a:t>Expiry in rupees + transfers that fix both problems at once</a:t>
-            </a:r>
-            <a:endParaRPr lang="en-US" sz="1450" dirty="0"/>
+              <a:t>Stock forecasts — who runs out of what, and when</a:t>
+            </a:r>
+            <a:endParaRPr lang="en-US" sz="1350" dirty="0"/>
           </a:p>
           <a:p>
             <a:pPr marL="342900" indent="-342900">
               <a:lnSpc>
-                <a:spcPct val="105000"/>
+                <a:spcPct val="103000"/>
               </a:lnSpc>
               <a:spcAft>
-                <a:spcPts val="1100"/>
+                <a:spcPts val="800"/>
               </a:spcAft>
               <a:buSzPct val="100000"/>
               <a:buChar char="•"/>
             </a:pPr>
             <a:r>
-              <a:rPr lang="en-US" sz="1450" dirty="0">
+              <a:rPr lang="en-US" sz="1350" dirty="0">
                 <a:solidFill>
                   <a:srgbClr val="E4F1F5"/>
                 </a:solidFill>
@@ -7100,9 +7323,33 @@
                 <a:ea typeface="Calibri" pitchFamily="34" charset="-122"/>
                 <a:cs typeface="Calibri" pitchFamily="34" charset="-120"/>
               </a:rPr>
+              <a:t>Expiry in rupees + transfers that fix both at once</a:t>
+            </a:r>
+            <a:endParaRPr lang="en-US" sz="1350" dirty="0"/>
+          </a:p>
+          <a:p>
+            <a:pPr marL="342900" indent="-342900">
+              <a:lnSpc>
+                <a:spcPct val="103000"/>
+              </a:lnSpc>
+              <a:spcAft>
+                <a:spcPts val="800"/>
+              </a:spcAft>
+              <a:buSzPct val="100000"/>
+              <a:buChar char="•"/>
+            </a:pPr>
+            <a:r>
+              <a:rPr lang="en-US" sz="1350" dirty="0">
+                <a:solidFill>
+                  <a:srgbClr val="E4F1F5"/>
+                </a:solidFill>
+                <a:latin typeface="Calibri" pitchFamily="34" charset="0"/>
+                <a:ea typeface="Calibri" pitchFamily="34" charset="-122"/>
+                <a:cs typeface="Calibri" pitchFamily="34" charset="-120"/>
+              </a:rPr>
               <a:t>A one-click weekly brief in plain language</a:t>
             </a:r>
-            <a:endParaRPr lang="en-US" sz="1450" dirty="0"/>
+            <a:endParaRPr lang="en-US" sz="1350" dirty="0"/>
           </a:p>
         </p:txBody>
       </p:sp>
@@ -8146,7 +8393,7 @@
                 <a:ea typeface="Cambria" pitchFamily="34" charset="-122"/>
                 <a:cs typeface="Cambria" pitchFamily="34" charset="-120"/>
               </a:rPr>
-              <a:t>z = 16.6</a:t>
+              <a:t>16.6σ</a:t>
             </a:r>
             <a:endParaRPr lang="en-US" sz="2700" dirty="0"/>
           </a:p>
@@ -8185,7 +8432,7 @@
                 <a:ea typeface="Calibri" pitchFamily="34" charset="-122"/>
                 <a:cs typeface="Calibri" pitchFamily="34" charset="-120"/>
               </a:rPr>
-              <a:t>standard deviations above baseline</a:t>
+              <a:t>peak centre, above its baseline</a:t>
             </a:r>
             <a:endParaRPr lang="en-US" sz="1200" dirty="0"/>
           </a:p>

</xml_diff>

<commit_message>
Deck: tricolour radar motif to match the new logo; tidy title subtitle
Recolour the decorative radar rings on the title/insight/close slides to
the Indian tricolour (saffron, white, green) so they match the app logo,
and narrow the title subtitle so it clears the rings.
</commit_message>
<xml_diff>
--- a/pitch/Arogya-Radar-Pitch.pptx
+++ b/pitch/Arogya-Radar-Pitch.pptx
@@ -2476,10 +2476,10 @@
           <a:prstGeom prst="ellipse">
             <a:avLst/>
           </a:prstGeom>
-          <a:ln w="15875">
+          <a:ln w="20320">
             <a:solidFill>
-              <a:srgbClr val="5EEAD4">
-                <a:alpha val="75000"/>
+              <a:srgbClr val="FF9933">
+                <a:alpha val="88000"/>
               </a:srgbClr>
             </a:solidFill>
             <a:prstDash val="solid"/>
@@ -2494,16 +2494,16 @@
         </p:nvSpPr>
         <p:spPr>
           <a:xfrm>
-            <a:off x="8412480" y="2194560"/>
-            <a:ext cx="2468880" cy="2468880"/>
+            <a:off x="8503920" y="2286000"/>
+            <a:ext cx="2286000" cy="2286000"/>
           </a:xfrm>
           <a:prstGeom prst="ellipse">
             <a:avLst/>
           </a:prstGeom>
-          <a:ln w="15875">
+          <a:ln w="20320">
             <a:solidFill>
-              <a:srgbClr val="5EEAD4">
-                <a:alpha val="75000"/>
+              <a:srgbClr val="FFFFFF">
+                <a:alpha val="88000"/>
               </a:srgbClr>
             </a:solidFill>
             <a:prstDash val="solid"/>
@@ -2518,16 +2518,16 @@
         </p:nvSpPr>
         <p:spPr>
           <a:xfrm>
-            <a:off x="8869680" y="2651760"/>
-            <a:ext cx="1554480" cy="1554480"/>
+            <a:off x="9079992" y="2862072"/>
+            <a:ext cx="1133856" cy="1133856"/>
           </a:xfrm>
           <a:prstGeom prst="ellipse">
             <a:avLst/>
           </a:prstGeom>
-          <a:ln w="15875">
+          <a:ln w="20320">
             <a:solidFill>
-              <a:srgbClr val="5EEAD4">
-                <a:alpha val="75000"/>
+              <a:srgbClr val="17A34A">
+                <a:alpha val="88000"/>
               </a:srgbClr>
             </a:solidFill>
             <a:prstDash val="solid"/>
@@ -2542,32 +2542,8 @@
         </p:nvSpPr>
         <p:spPr>
           <a:xfrm>
-            <a:off x="9262872" y="3044952"/>
-            <a:ext cx="768096" cy="768096"/>
-          </a:xfrm>
-          <a:prstGeom prst="ellipse">
-            <a:avLst/>
-          </a:prstGeom>
-          <a:ln w="15875">
-            <a:solidFill>
-              <a:srgbClr val="5EEAD4">
-                <a:alpha val="75000"/>
-              </a:srgbClr>
-            </a:solidFill>
-            <a:prstDash val="solid"/>
-          </a:ln>
-        </p:spPr>
-      </p:sp>
-      <p:sp>
-        <p:nvSpPr>
-          <p:cNvPr id="6" name="Shape 4"/>
-          <p:cNvSpPr/>
-          <p:nvPr/>
-        </p:nvSpPr>
-        <p:spPr>
-          <a:xfrm>
-            <a:off x="9564624" y="3346704"/>
-            <a:ext cx="164592" cy="164592"/>
+            <a:off x="9573768" y="3355848"/>
+            <a:ext cx="146304" cy="146304"/>
           </a:xfrm>
           <a:prstGeom prst="ellipse">
             <a:avLst/>
@@ -2580,13 +2556,13 @@
       </p:sp>
       <p:sp>
         <p:nvSpPr>
-          <p:cNvPr id="7" name="Shape 5"/>
-          <p:cNvSpPr/>
-          <p:nvPr/>
-        </p:nvSpPr>
-        <p:spPr>
-          <a:xfrm>
-            <a:off x="10488168" y="2770632"/>
+          <p:cNvPr id="6" name="Shape 4"/>
+          <p:cNvSpPr/>
+          <p:nvPr/>
+        </p:nvSpPr>
+        <p:spPr>
+          <a:xfrm>
+            <a:off x="10725912" y="2715768"/>
             <a:ext cx="237744" cy="237744"/>
           </a:xfrm>
           <a:prstGeom prst="ellipse">
@@ -2600,7 +2576,7 @@
       </p:sp>
       <p:sp>
         <p:nvSpPr>
-          <p:cNvPr id="8" name="Text 6"/>
+          <p:cNvPr id="7" name="Text 5"/>
           <p:cNvSpPr/>
           <p:nvPr/>
         </p:nvSpPr>
@@ -2639,7 +2615,7 @@
       </p:sp>
       <p:sp>
         <p:nvSpPr>
-          <p:cNvPr id="9" name="Text 7"/>
+          <p:cNvPr id="8" name="Text 6"/>
           <p:cNvSpPr/>
           <p:nvPr/>
         </p:nvSpPr>
@@ -2678,14 +2654,14 @@
       </p:sp>
       <p:sp>
         <p:nvSpPr>
-          <p:cNvPr id="10" name="Text 8"/>
+          <p:cNvPr id="9" name="Text 7"/>
           <p:cNvSpPr/>
           <p:nvPr/>
         </p:nvSpPr>
         <p:spPr>
           <a:xfrm>
             <a:off x="594360" y="2971800"/>
-            <a:ext cx="7589520" cy="914400"/>
+            <a:ext cx="6766560" cy="1280160"/>
           </a:xfrm>
           <a:prstGeom prst="rect">
             <a:avLst/>
@@ -2720,7 +2696,7 @@
       </p:sp>
       <p:sp>
         <p:nvSpPr>
-          <p:cNvPr id="11" name="Shape 9"/>
+          <p:cNvPr id="10" name="Shape 8"/>
           <p:cNvSpPr/>
           <p:nvPr/>
         </p:nvSpPr>
@@ -2743,7 +2719,7 @@
       </p:sp>
       <p:sp>
         <p:nvSpPr>
-          <p:cNvPr id="12" name="Text 10"/>
+          <p:cNvPr id="11" name="Text 9"/>
           <p:cNvSpPr/>
           <p:nvPr/>
         </p:nvSpPr>
@@ -2796,7 +2772,7 @@
       </p:sp>
       <p:sp>
         <p:nvSpPr>
-          <p:cNvPr id="13" name="Text 11"/>
+          <p:cNvPr id="12" name="Text 10"/>
           <p:cNvSpPr/>
           <p:nvPr/>
         </p:nvSpPr>
@@ -2835,7 +2811,7 @@
       </p:sp>
       <p:sp>
         <p:nvSpPr>
-          <p:cNvPr id="14" name="Text 12"/>
+          <p:cNvPr id="13" name="Text 11"/>
           <p:cNvSpPr/>
           <p:nvPr/>
         </p:nvSpPr>
@@ -4785,10 +4761,10 @@
           <a:prstGeom prst="ellipse">
             <a:avLst/>
           </a:prstGeom>
-          <a:ln w="15875">
+          <a:ln w="20320">
             <a:solidFill>
-              <a:srgbClr val="5EEAD4">
-                <a:alpha val="75000"/>
+              <a:srgbClr val="FF9933">
+                <a:alpha val="88000"/>
               </a:srgbClr>
             </a:solidFill>
             <a:prstDash val="solid"/>
@@ -4803,16 +4779,16 @@
         </p:nvSpPr>
         <p:spPr>
           <a:xfrm>
-            <a:off x="9006840" y="2514600"/>
-            <a:ext cx="2468880" cy="2468880"/>
+            <a:off x="9098280" y="2606040"/>
+            <a:ext cx="2286000" cy="2286000"/>
           </a:xfrm>
           <a:prstGeom prst="ellipse">
             <a:avLst/>
           </a:prstGeom>
-          <a:ln w="15875">
+          <a:ln w="20320">
             <a:solidFill>
-              <a:srgbClr val="5EEAD4">
-                <a:alpha val="75000"/>
+              <a:srgbClr val="FFFFFF">
+                <a:alpha val="88000"/>
               </a:srgbClr>
             </a:solidFill>
             <a:prstDash val="solid"/>
@@ -4827,16 +4803,16 @@
         </p:nvSpPr>
         <p:spPr>
           <a:xfrm>
-            <a:off x="9464040" y="2971800"/>
-            <a:ext cx="1554480" cy="1554480"/>
+            <a:off x="9674352" y="3182112"/>
+            <a:ext cx="1133856" cy="1133856"/>
           </a:xfrm>
           <a:prstGeom prst="ellipse">
             <a:avLst/>
           </a:prstGeom>
-          <a:ln w="15875">
+          <a:ln w="20320">
             <a:solidFill>
-              <a:srgbClr val="5EEAD4">
-                <a:alpha val="75000"/>
+              <a:srgbClr val="17A34A">
+                <a:alpha val="88000"/>
               </a:srgbClr>
             </a:solidFill>
             <a:prstDash val="solid"/>
@@ -4851,32 +4827,8 @@
         </p:nvSpPr>
         <p:spPr>
           <a:xfrm>
-            <a:off x="9857232" y="3364992"/>
-            <a:ext cx="768096" cy="768096"/>
-          </a:xfrm>
-          <a:prstGeom prst="ellipse">
-            <a:avLst/>
-          </a:prstGeom>
-          <a:ln w="15875">
-            <a:solidFill>
-              <a:srgbClr val="5EEAD4">
-                <a:alpha val="75000"/>
-              </a:srgbClr>
-            </a:solidFill>
-            <a:prstDash val="solid"/>
-          </a:ln>
-        </p:spPr>
-      </p:sp>
-      <p:sp>
-        <p:nvSpPr>
-          <p:cNvPr id="6" name="Shape 4"/>
-          <p:cNvSpPr/>
-          <p:nvPr/>
-        </p:nvSpPr>
-        <p:spPr>
-          <a:xfrm>
-            <a:off x="10158984" y="3666744"/>
-            <a:ext cx="164592" cy="164592"/>
+            <a:off x="10168128" y="3675888"/>
+            <a:ext cx="146304" cy="146304"/>
           </a:xfrm>
           <a:prstGeom prst="ellipse">
             <a:avLst/>
@@ -4889,13 +4841,13 @@
       </p:sp>
       <p:sp>
         <p:nvSpPr>
-          <p:cNvPr id="7" name="Shape 5"/>
-          <p:cNvSpPr/>
-          <p:nvPr/>
-        </p:nvSpPr>
-        <p:spPr>
-          <a:xfrm>
-            <a:off x="11082528" y="3090672"/>
+          <p:cNvPr id="6" name="Shape 4"/>
+          <p:cNvSpPr/>
+          <p:nvPr/>
+        </p:nvSpPr>
+        <p:spPr>
+          <a:xfrm>
+            <a:off x="11320272" y="3035808"/>
             <a:ext cx="237744" cy="237744"/>
           </a:xfrm>
           <a:prstGeom prst="ellipse">
@@ -4909,7 +4861,7 @@
       </p:sp>
       <p:sp>
         <p:nvSpPr>
-          <p:cNvPr id="8" name="Text 6"/>
+          <p:cNvPr id="7" name="Text 5"/>
           <p:cNvSpPr/>
           <p:nvPr/>
         </p:nvSpPr>
@@ -4948,7 +4900,7 @@
       </p:sp>
       <p:sp>
         <p:nvSpPr>
-          <p:cNvPr id="9" name="Shape 7"/>
+          <p:cNvPr id="8" name="Shape 6"/>
           <p:cNvSpPr/>
           <p:nvPr/>
         </p:nvSpPr>
@@ -4968,7 +4920,7 @@
       </p:sp>
       <p:sp>
         <p:nvSpPr>
-          <p:cNvPr id="10" name="Text 8"/>
+          <p:cNvPr id="9" name="Text 7"/>
           <p:cNvSpPr/>
           <p:nvPr/>
         </p:nvSpPr>
@@ -5007,7 +4959,7 @@
       </p:sp>
       <p:sp>
         <p:nvSpPr>
-          <p:cNvPr id="11" name="Text 9"/>
+          <p:cNvPr id="10" name="Text 8"/>
           <p:cNvSpPr/>
           <p:nvPr/>
         </p:nvSpPr>
@@ -5046,7 +4998,7 @@
       </p:sp>
       <p:sp>
         <p:nvSpPr>
-          <p:cNvPr id="12" name="Shape 10"/>
+          <p:cNvPr id="11" name="Shape 9"/>
           <p:cNvSpPr/>
           <p:nvPr/>
         </p:nvSpPr>
@@ -5066,7 +5018,7 @@
       </p:sp>
       <p:sp>
         <p:nvSpPr>
-          <p:cNvPr id="13" name="Text 11"/>
+          <p:cNvPr id="12" name="Text 10"/>
           <p:cNvSpPr/>
           <p:nvPr/>
         </p:nvSpPr>
@@ -5105,7 +5057,7 @@
       </p:sp>
       <p:sp>
         <p:nvSpPr>
-          <p:cNvPr id="14" name="Text 12"/>
+          <p:cNvPr id="13" name="Text 11"/>
           <p:cNvSpPr/>
           <p:nvPr/>
         </p:nvSpPr>
@@ -5144,7 +5096,7 @@
       </p:sp>
       <p:sp>
         <p:nvSpPr>
-          <p:cNvPr id="15" name="Shape 13"/>
+          <p:cNvPr id="14" name="Shape 12"/>
           <p:cNvSpPr/>
           <p:nvPr/>
         </p:nvSpPr>
@@ -5164,7 +5116,7 @@
       </p:sp>
       <p:sp>
         <p:nvSpPr>
-          <p:cNvPr id="16" name="Text 14"/>
+          <p:cNvPr id="15" name="Text 13"/>
           <p:cNvSpPr/>
           <p:nvPr/>
         </p:nvSpPr>
@@ -5203,7 +5155,7 @@
       </p:sp>
       <p:sp>
         <p:nvSpPr>
-          <p:cNvPr id="17" name="Text 15"/>
+          <p:cNvPr id="16" name="Text 14"/>
           <p:cNvSpPr/>
           <p:nvPr/>
         </p:nvSpPr>
@@ -5242,7 +5194,7 @@
       </p:sp>
       <p:sp>
         <p:nvSpPr>
-          <p:cNvPr id="18" name="Shape 16"/>
+          <p:cNvPr id="17" name="Shape 15"/>
           <p:cNvSpPr/>
           <p:nvPr/>
         </p:nvSpPr>
@@ -5265,7 +5217,7 @@
       </p:sp>
       <p:sp>
         <p:nvSpPr>
-          <p:cNvPr id="19" name="Text 17"/>
+          <p:cNvPr id="18" name="Text 16"/>
           <p:cNvSpPr/>
           <p:nvPr/>
         </p:nvSpPr>
@@ -5318,7 +5270,7 @@
       </p:sp>
       <p:sp>
         <p:nvSpPr>
-          <p:cNvPr id="20" name="Text 18"/>
+          <p:cNvPr id="19" name="Text 17"/>
           <p:cNvSpPr/>
           <p:nvPr/>
         </p:nvSpPr>
@@ -5399,7 +5351,7 @@
       </p:sp>
       <p:sp>
         <p:nvSpPr>
-          <p:cNvPr id="21" name="Text 19"/>
+          <p:cNvPr id="20" name="Text 18"/>
           <p:cNvSpPr/>
           <p:nvPr/>
         </p:nvSpPr>
@@ -5452,7 +5404,7 @@
       </p:sp>
       <p:sp>
         <p:nvSpPr>
-          <p:cNvPr id="22" name="Text 20"/>
+          <p:cNvPr id="21" name="Text 19"/>
           <p:cNvSpPr/>
           <p:nvPr/>
         </p:nvSpPr>
@@ -5491,7 +5443,7 @@
       </p:sp>
       <p:sp>
         <p:nvSpPr>
-          <p:cNvPr id="23" name="Text 21"/>
+          <p:cNvPr id="22" name="Text 20"/>
           <p:cNvSpPr/>
           <p:nvPr/>
         </p:nvSpPr>
@@ -5530,7 +5482,7 @@
       </p:sp>
       <p:sp>
         <p:nvSpPr>
-          <p:cNvPr id="24" name="Text 22"/>
+          <p:cNvPr id="23" name="Text 21"/>
           <p:cNvSpPr/>
           <p:nvPr/>
         </p:nvSpPr>
@@ -6362,10 +6314,10 @@
           <a:prstGeom prst="ellipse">
             <a:avLst/>
           </a:prstGeom>
-          <a:ln w="15875">
+          <a:ln w="20320">
             <a:solidFill>
-              <a:srgbClr val="5EEAD4">
-                <a:alpha val="75000"/>
+              <a:srgbClr val="FF9933">
+                <a:alpha val="88000"/>
               </a:srgbClr>
             </a:solidFill>
             <a:prstDash val="solid"/>
@@ -6380,16 +6332,16 @@
         </p:nvSpPr>
         <p:spPr>
           <a:xfrm>
-            <a:off x="8915400" y="2331720"/>
-            <a:ext cx="2468880" cy="2468880"/>
+            <a:off x="9006840" y="2423160"/>
+            <a:ext cx="2286000" cy="2286000"/>
           </a:xfrm>
           <a:prstGeom prst="ellipse">
             <a:avLst/>
           </a:prstGeom>
-          <a:ln w="15875">
+          <a:ln w="20320">
             <a:solidFill>
-              <a:srgbClr val="5EEAD4">
-                <a:alpha val="75000"/>
+              <a:srgbClr val="FFFFFF">
+                <a:alpha val="88000"/>
               </a:srgbClr>
             </a:solidFill>
             <a:prstDash val="solid"/>
@@ -6404,16 +6356,16 @@
         </p:nvSpPr>
         <p:spPr>
           <a:xfrm>
-            <a:off x="9372600" y="2788920"/>
-            <a:ext cx="1554480" cy="1554480"/>
+            <a:off x="9582912" y="2999232"/>
+            <a:ext cx="1133856" cy="1133856"/>
           </a:xfrm>
           <a:prstGeom prst="ellipse">
             <a:avLst/>
           </a:prstGeom>
-          <a:ln w="15875">
+          <a:ln w="20320">
             <a:solidFill>
-              <a:srgbClr val="5EEAD4">
-                <a:alpha val="75000"/>
+              <a:srgbClr val="17A34A">
+                <a:alpha val="88000"/>
               </a:srgbClr>
             </a:solidFill>
             <a:prstDash val="solid"/>
@@ -6428,32 +6380,8 @@
         </p:nvSpPr>
         <p:spPr>
           <a:xfrm>
-            <a:off x="9765792" y="3182112"/>
-            <a:ext cx="768096" cy="768096"/>
-          </a:xfrm>
-          <a:prstGeom prst="ellipse">
-            <a:avLst/>
-          </a:prstGeom>
-          <a:ln w="15875">
-            <a:solidFill>
-              <a:srgbClr val="5EEAD4">
-                <a:alpha val="75000"/>
-              </a:srgbClr>
-            </a:solidFill>
-            <a:prstDash val="solid"/>
-          </a:ln>
-        </p:spPr>
-      </p:sp>
-      <p:sp>
-        <p:nvSpPr>
-          <p:cNvPr id="6" name="Shape 4"/>
-          <p:cNvSpPr/>
-          <p:nvPr/>
-        </p:nvSpPr>
-        <p:spPr>
-          <a:xfrm>
-            <a:off x="10067544" y="3483864"/>
-            <a:ext cx="164592" cy="164592"/>
+            <a:off x="10076688" y="3493008"/>
+            <a:ext cx="146304" cy="146304"/>
           </a:xfrm>
           <a:prstGeom prst="ellipse">
             <a:avLst/>
@@ -6466,13 +6394,13 @@
       </p:sp>
       <p:sp>
         <p:nvSpPr>
-          <p:cNvPr id="7" name="Shape 5"/>
-          <p:cNvSpPr/>
-          <p:nvPr/>
-        </p:nvSpPr>
-        <p:spPr>
-          <a:xfrm>
-            <a:off x="10991088" y="2907792"/>
+          <p:cNvPr id="6" name="Shape 4"/>
+          <p:cNvSpPr/>
+          <p:nvPr/>
+        </p:nvSpPr>
+        <p:spPr>
+          <a:xfrm>
+            <a:off x="11228832" y="2852928"/>
             <a:ext cx="237744" cy="237744"/>
           </a:xfrm>
           <a:prstGeom prst="ellipse">
@@ -6486,7 +6414,7 @@
       </p:sp>
       <p:sp>
         <p:nvSpPr>
-          <p:cNvPr id="8" name="Text 6"/>
+          <p:cNvPr id="7" name="Text 5"/>
           <p:cNvSpPr/>
           <p:nvPr/>
         </p:nvSpPr>
@@ -6525,7 +6453,7 @@
       </p:sp>
       <p:sp>
         <p:nvSpPr>
-          <p:cNvPr id="9" name="Text 7"/>
+          <p:cNvPr id="8" name="Text 6"/>
           <p:cNvSpPr/>
           <p:nvPr/>
         </p:nvSpPr>
@@ -6567,7 +6495,7 @@
       </p:sp>
       <p:sp>
         <p:nvSpPr>
-          <p:cNvPr id="10" name="Text 8"/>
+          <p:cNvPr id="9" name="Text 7"/>
           <p:cNvSpPr/>
           <p:nvPr/>
         </p:nvSpPr>
@@ -6609,7 +6537,7 @@
       </p:sp>
       <p:sp>
         <p:nvSpPr>
-          <p:cNvPr id="11" name="Text 9"/>
+          <p:cNvPr id="10" name="Text 8"/>
           <p:cNvSpPr/>
           <p:nvPr/>
         </p:nvSpPr>
@@ -6648,7 +6576,7 @@
       </p:sp>
       <p:sp>
         <p:nvSpPr>
-          <p:cNvPr id="12" name="Text 10"/>
+          <p:cNvPr id="11" name="Text 9"/>
           <p:cNvSpPr/>
           <p:nvPr/>
         </p:nvSpPr>
@@ -6687,7 +6615,7 @@
       </p:sp>
       <p:sp>
         <p:nvSpPr>
-          <p:cNvPr id="13" name="Text 11"/>
+          <p:cNvPr id="12" name="Text 10"/>
           <p:cNvSpPr/>
           <p:nvPr/>
         </p:nvSpPr>

</xml_diff>

<commit_message>
Deck: use the current app logo (tricolour rings + heartbeat pulse)
Replace the decorative radar-with-blip motif on the title/insight/close
slides with the exact app logo mark: three tricolour rings and the mint
heartbeat pulse, matching Logo.tsx.
</commit_message>
<xml_diff>
--- a/pitch/Arogya-Radar-Pitch.pptx
+++ b/pitch/Arogya-Radar-Pitch.pptx
@@ -2476,10 +2476,10 @@
           <a:prstGeom prst="ellipse">
             <a:avLst/>
           </a:prstGeom>
-          <a:ln w="20320">
+          <a:ln w="22860">
             <a:solidFill>
               <a:srgbClr val="FF9933">
-                <a:alpha val="88000"/>
+                <a:alpha val="92000"/>
               </a:srgbClr>
             </a:solidFill>
             <a:prstDash val="solid"/>
@@ -2500,10 +2500,10 @@
           <a:prstGeom prst="ellipse">
             <a:avLst/>
           </a:prstGeom>
-          <a:ln w="20320">
+          <a:ln w="22860">
             <a:solidFill>
               <a:srgbClr val="FFFFFF">
-                <a:alpha val="88000"/>
+                <a:alpha val="92000"/>
               </a:srgbClr>
             </a:solidFill>
             <a:prstDash val="solid"/>
@@ -2524,10 +2524,10 @@
           <a:prstGeom prst="ellipse">
             <a:avLst/>
           </a:prstGeom>
-          <a:ln w="20320">
+          <a:ln w="22860">
             <a:solidFill>
               <a:srgbClr val="17A34A">
-                <a:alpha val="88000"/>
+                <a:alpha val="92000"/>
               </a:srgbClr>
             </a:solidFill>
             <a:prstDash val="solid"/>
@@ -2542,16 +2542,19 @@
         </p:nvSpPr>
         <p:spPr>
           <a:xfrm>
-            <a:off x="9573768" y="3355848"/>
-            <a:ext cx="146304" cy="146304"/>
-          </a:xfrm>
-          <a:prstGeom prst="ellipse">
-            <a:avLst/>
-          </a:prstGeom>
-          <a:solidFill>
-            <a:srgbClr val="5EEAD4"/>
-          </a:solidFill>
-          <a:ln/>
+            <a:off x="7735824" y="3429000"/>
+            <a:ext cx="1042416" cy="0"/>
+          </a:xfrm>
+          <a:prstGeom prst="line">
+            <a:avLst/>
+          </a:prstGeom>
+          <a:noFill/>
+          <a:ln w="28575">
+            <a:solidFill>
+              <a:srgbClr val="5EEAD4"/>
+            </a:solidFill>
+            <a:prstDash val="solid"/>
+          </a:ln>
         </p:spPr>
       </p:sp>
       <p:sp>
@@ -2562,21 +2565,139 @@
         </p:nvSpPr>
         <p:spPr>
           <a:xfrm>
-            <a:off x="10725912" y="2715768"/>
-            <a:ext cx="237744" cy="237744"/>
-          </a:xfrm>
-          <a:prstGeom prst="ellipse">
-            <a:avLst/>
-          </a:prstGeom>
-          <a:solidFill>
-            <a:srgbClr val="DC2626"/>
-          </a:solidFill>
-          <a:ln/>
-        </p:spPr>
-      </p:sp>
-      <p:sp>
-        <p:nvSpPr>
-          <p:cNvPr id="7" name="Text 5"/>
+            <a:off x="8778240" y="3429000"/>
+            <a:ext cx="304038" cy="0"/>
+          </a:xfrm>
+          <a:prstGeom prst="line">
+            <a:avLst/>
+          </a:prstGeom>
+          <a:noFill/>
+          <a:ln w="28575">
+            <a:solidFill>
+              <a:srgbClr val="5EEAD4"/>
+            </a:solidFill>
+            <a:prstDash val="solid"/>
+          </a:ln>
+        </p:spPr>
+      </p:sp>
+      <p:sp>
+        <p:nvSpPr>
+          <p:cNvPr id="7" name="Shape 5"/>
+          <p:cNvSpPr/>
+          <p:nvPr/>
+        </p:nvSpPr>
+        <p:spPr>
+          <a:xfrm flipV="1">
+            <a:off x="9082278" y="2473452"/>
+            <a:ext cx="304038" cy="955548"/>
+          </a:xfrm>
+          <a:prstGeom prst="line">
+            <a:avLst/>
+          </a:prstGeom>
+          <a:noFill/>
+          <a:ln w="28575">
+            <a:solidFill>
+              <a:srgbClr val="5EEAD4"/>
+            </a:solidFill>
+            <a:prstDash val="solid"/>
+          </a:ln>
+        </p:spPr>
+      </p:sp>
+      <p:sp>
+        <p:nvSpPr>
+          <p:cNvPr id="8" name="Shape 6"/>
+          <p:cNvSpPr/>
+          <p:nvPr/>
+        </p:nvSpPr>
+        <p:spPr>
+          <a:xfrm>
+            <a:off x="9386316" y="2473452"/>
+            <a:ext cx="347472" cy="1911096"/>
+          </a:xfrm>
+          <a:prstGeom prst="line">
+            <a:avLst/>
+          </a:prstGeom>
+          <a:noFill/>
+          <a:ln w="28575">
+            <a:solidFill>
+              <a:srgbClr val="5EEAD4"/>
+            </a:solidFill>
+            <a:prstDash val="solid"/>
+          </a:ln>
+        </p:spPr>
+      </p:sp>
+      <p:sp>
+        <p:nvSpPr>
+          <p:cNvPr id="9" name="Shape 7"/>
+          <p:cNvSpPr/>
+          <p:nvPr/>
+        </p:nvSpPr>
+        <p:spPr>
+          <a:xfrm flipV="1">
+            <a:off x="9733788" y="2907792"/>
+            <a:ext cx="304038" cy="1476756"/>
+          </a:xfrm>
+          <a:prstGeom prst="line">
+            <a:avLst/>
+          </a:prstGeom>
+          <a:noFill/>
+          <a:ln w="28575">
+            <a:solidFill>
+              <a:srgbClr val="5EEAD4"/>
+            </a:solidFill>
+            <a:prstDash val="solid"/>
+          </a:ln>
+        </p:spPr>
+      </p:sp>
+      <p:sp>
+        <p:nvSpPr>
+          <p:cNvPr id="10" name="Shape 8"/>
+          <p:cNvSpPr/>
+          <p:nvPr/>
+        </p:nvSpPr>
+        <p:spPr>
+          <a:xfrm>
+            <a:off x="10037826" y="2907792"/>
+            <a:ext cx="260604" cy="521208"/>
+          </a:xfrm>
+          <a:prstGeom prst="line">
+            <a:avLst/>
+          </a:prstGeom>
+          <a:noFill/>
+          <a:ln w="28575">
+            <a:solidFill>
+              <a:srgbClr val="5EEAD4"/>
+            </a:solidFill>
+            <a:prstDash val="solid"/>
+          </a:ln>
+        </p:spPr>
+      </p:sp>
+      <p:sp>
+        <p:nvSpPr>
+          <p:cNvPr id="11" name="Shape 9"/>
+          <p:cNvSpPr/>
+          <p:nvPr/>
+        </p:nvSpPr>
+        <p:spPr>
+          <a:xfrm>
+            <a:off x="10298430" y="3429000"/>
+            <a:ext cx="1259586" cy="0"/>
+          </a:xfrm>
+          <a:prstGeom prst="line">
+            <a:avLst/>
+          </a:prstGeom>
+          <a:noFill/>
+          <a:ln w="28575">
+            <a:solidFill>
+              <a:srgbClr val="5EEAD4"/>
+            </a:solidFill>
+            <a:prstDash val="solid"/>
+          </a:ln>
+        </p:spPr>
+      </p:sp>
+      <p:sp>
+        <p:nvSpPr>
+          <p:cNvPr id="12" name="Text 10"/>
           <p:cNvSpPr/>
           <p:nvPr/>
         </p:nvSpPr>
@@ -2615,7 +2736,7 @@
       </p:sp>
       <p:sp>
         <p:nvSpPr>
-          <p:cNvPr id="8" name="Text 6"/>
+          <p:cNvPr id="13" name="Text 11"/>
           <p:cNvSpPr/>
           <p:nvPr/>
         </p:nvSpPr>
@@ -2654,7 +2775,7 @@
       </p:sp>
       <p:sp>
         <p:nvSpPr>
-          <p:cNvPr id="9" name="Text 7"/>
+          <p:cNvPr id="14" name="Text 12"/>
           <p:cNvSpPr/>
           <p:nvPr/>
         </p:nvSpPr>
@@ -2696,7 +2817,7 @@
       </p:sp>
       <p:sp>
         <p:nvSpPr>
-          <p:cNvPr id="10" name="Shape 8"/>
+          <p:cNvPr id="15" name="Shape 13"/>
           <p:cNvSpPr/>
           <p:nvPr/>
         </p:nvSpPr>
@@ -2719,7 +2840,7 @@
       </p:sp>
       <p:sp>
         <p:nvSpPr>
-          <p:cNvPr id="11" name="Text 9"/>
+          <p:cNvPr id="16" name="Text 14"/>
           <p:cNvSpPr/>
           <p:nvPr/>
         </p:nvSpPr>
@@ -2772,7 +2893,7 @@
       </p:sp>
       <p:sp>
         <p:nvSpPr>
-          <p:cNvPr id="12" name="Text 10"/>
+          <p:cNvPr id="17" name="Text 15"/>
           <p:cNvSpPr/>
           <p:nvPr/>
         </p:nvSpPr>
@@ -2811,7 +2932,7 @@
       </p:sp>
       <p:sp>
         <p:nvSpPr>
-          <p:cNvPr id="13" name="Text 11"/>
+          <p:cNvPr id="18" name="Text 16"/>
           <p:cNvSpPr/>
           <p:nvPr/>
         </p:nvSpPr>
@@ -4761,10 +4882,10 @@
           <a:prstGeom prst="ellipse">
             <a:avLst/>
           </a:prstGeom>
-          <a:ln w="20320">
+          <a:ln w="22860">
             <a:solidFill>
               <a:srgbClr val="FF9933">
-                <a:alpha val="88000"/>
+                <a:alpha val="92000"/>
               </a:srgbClr>
             </a:solidFill>
             <a:prstDash val="solid"/>
@@ -4785,10 +4906,10 @@
           <a:prstGeom prst="ellipse">
             <a:avLst/>
           </a:prstGeom>
-          <a:ln w="20320">
+          <a:ln w="22860">
             <a:solidFill>
               <a:srgbClr val="FFFFFF">
-                <a:alpha val="88000"/>
+                <a:alpha val="92000"/>
               </a:srgbClr>
             </a:solidFill>
             <a:prstDash val="solid"/>
@@ -4809,10 +4930,10 @@
           <a:prstGeom prst="ellipse">
             <a:avLst/>
           </a:prstGeom>
-          <a:ln w="20320">
+          <a:ln w="22860">
             <a:solidFill>
               <a:srgbClr val="17A34A">
-                <a:alpha val="88000"/>
+                <a:alpha val="92000"/>
               </a:srgbClr>
             </a:solidFill>
             <a:prstDash val="solid"/>
@@ -4827,8 +4948,208 @@
         </p:nvSpPr>
         <p:spPr>
           <a:xfrm>
-            <a:off x="10168128" y="3675888"/>
-            <a:ext cx="146304" cy="146304"/>
+            <a:off x="8330184" y="3749040"/>
+            <a:ext cx="1042416" cy="0"/>
+          </a:xfrm>
+          <a:prstGeom prst="line">
+            <a:avLst/>
+          </a:prstGeom>
+          <a:noFill/>
+          <a:ln w="28575">
+            <a:solidFill>
+              <a:srgbClr val="5EEAD4"/>
+            </a:solidFill>
+            <a:prstDash val="solid"/>
+          </a:ln>
+        </p:spPr>
+      </p:sp>
+      <p:sp>
+        <p:nvSpPr>
+          <p:cNvPr id="6" name="Shape 4"/>
+          <p:cNvSpPr/>
+          <p:nvPr/>
+        </p:nvSpPr>
+        <p:spPr>
+          <a:xfrm>
+            <a:off x="9372600" y="3749040"/>
+            <a:ext cx="304038" cy="0"/>
+          </a:xfrm>
+          <a:prstGeom prst="line">
+            <a:avLst/>
+          </a:prstGeom>
+          <a:noFill/>
+          <a:ln w="28575">
+            <a:solidFill>
+              <a:srgbClr val="5EEAD4"/>
+            </a:solidFill>
+            <a:prstDash val="solid"/>
+          </a:ln>
+        </p:spPr>
+      </p:sp>
+      <p:sp>
+        <p:nvSpPr>
+          <p:cNvPr id="7" name="Shape 5"/>
+          <p:cNvSpPr/>
+          <p:nvPr/>
+        </p:nvSpPr>
+        <p:spPr>
+          <a:xfrm flipV="1">
+            <a:off x="9676638" y="2793492"/>
+            <a:ext cx="304038" cy="955548"/>
+          </a:xfrm>
+          <a:prstGeom prst="line">
+            <a:avLst/>
+          </a:prstGeom>
+          <a:noFill/>
+          <a:ln w="28575">
+            <a:solidFill>
+              <a:srgbClr val="5EEAD4"/>
+            </a:solidFill>
+            <a:prstDash val="solid"/>
+          </a:ln>
+        </p:spPr>
+      </p:sp>
+      <p:sp>
+        <p:nvSpPr>
+          <p:cNvPr id="8" name="Shape 6"/>
+          <p:cNvSpPr/>
+          <p:nvPr/>
+        </p:nvSpPr>
+        <p:spPr>
+          <a:xfrm>
+            <a:off x="9980676" y="2793492"/>
+            <a:ext cx="347472" cy="1911096"/>
+          </a:xfrm>
+          <a:prstGeom prst="line">
+            <a:avLst/>
+          </a:prstGeom>
+          <a:noFill/>
+          <a:ln w="28575">
+            <a:solidFill>
+              <a:srgbClr val="5EEAD4"/>
+            </a:solidFill>
+            <a:prstDash val="solid"/>
+          </a:ln>
+        </p:spPr>
+      </p:sp>
+      <p:sp>
+        <p:nvSpPr>
+          <p:cNvPr id="9" name="Shape 7"/>
+          <p:cNvSpPr/>
+          <p:nvPr/>
+        </p:nvSpPr>
+        <p:spPr>
+          <a:xfrm flipV="1">
+            <a:off x="10328148" y="3227832"/>
+            <a:ext cx="304038" cy="1476756"/>
+          </a:xfrm>
+          <a:prstGeom prst="line">
+            <a:avLst/>
+          </a:prstGeom>
+          <a:noFill/>
+          <a:ln w="28575">
+            <a:solidFill>
+              <a:srgbClr val="5EEAD4"/>
+            </a:solidFill>
+            <a:prstDash val="solid"/>
+          </a:ln>
+        </p:spPr>
+      </p:sp>
+      <p:sp>
+        <p:nvSpPr>
+          <p:cNvPr id="10" name="Shape 8"/>
+          <p:cNvSpPr/>
+          <p:nvPr/>
+        </p:nvSpPr>
+        <p:spPr>
+          <a:xfrm>
+            <a:off x="10632186" y="3227832"/>
+            <a:ext cx="260604" cy="521208"/>
+          </a:xfrm>
+          <a:prstGeom prst="line">
+            <a:avLst/>
+          </a:prstGeom>
+          <a:noFill/>
+          <a:ln w="28575">
+            <a:solidFill>
+              <a:srgbClr val="5EEAD4"/>
+            </a:solidFill>
+            <a:prstDash val="solid"/>
+          </a:ln>
+        </p:spPr>
+      </p:sp>
+      <p:sp>
+        <p:nvSpPr>
+          <p:cNvPr id="11" name="Shape 9"/>
+          <p:cNvSpPr/>
+          <p:nvPr/>
+        </p:nvSpPr>
+        <p:spPr>
+          <a:xfrm>
+            <a:off x="10892790" y="3749040"/>
+            <a:ext cx="1259586" cy="0"/>
+          </a:xfrm>
+          <a:prstGeom prst="line">
+            <a:avLst/>
+          </a:prstGeom>
+          <a:noFill/>
+          <a:ln w="28575">
+            <a:solidFill>
+              <a:srgbClr val="5EEAD4"/>
+            </a:solidFill>
+            <a:prstDash val="solid"/>
+          </a:ln>
+        </p:spPr>
+      </p:sp>
+      <p:sp>
+        <p:nvSpPr>
+          <p:cNvPr id="12" name="Text 10"/>
+          <p:cNvSpPr/>
+          <p:nvPr/>
+        </p:nvSpPr>
+        <p:spPr>
+          <a:xfrm>
+            <a:off x="594360" y="1234440"/>
+            <a:ext cx="8229600" cy="320040"/>
+          </a:xfrm>
+          <a:prstGeom prst="rect">
+            <a:avLst/>
+          </a:prstGeom>
+          <a:noFill/>
+          <a:ln/>
+        </p:spPr>
+        <p:txBody>
+          <a:bodyPr wrap="square" lIns="0" tIns="0" rIns="0" bIns="0" rtlCol="0" anchor="ctr"/>
+          <a:lstStyle/>
+          <a:p>
+            <a:pPr indent="0" marL="0">
+              <a:buNone/>
+            </a:pPr>
+            <a:r>
+              <a:rPr lang="en-US" sz="1300" b="1" spc="200" kern="0" dirty="0">
+                <a:solidFill>
+                  <a:srgbClr val="5EEAD4"/>
+                </a:solidFill>
+                <a:latin typeface="Calibri" pitchFamily="34" charset="0"/>
+                <a:ea typeface="Calibri" pitchFamily="34" charset="-122"/>
+                <a:cs typeface="Calibri" pitchFamily="34" charset="-120"/>
+              </a:rPr>
+              <a:t>WHAT A PILOT IN KALAHANDI DELIVERS</a:t>
+            </a:r>
+            <a:endParaRPr lang="en-US" sz="1300" dirty="0"/>
+          </a:p>
+        </p:txBody>
+      </p:sp>
+      <p:sp>
+        <p:nvSpPr>
+          <p:cNvPr id="13" name="Shape 11"/>
+          <p:cNvSpPr/>
+          <p:nvPr/>
+        </p:nvSpPr>
+        <p:spPr>
+          <a:xfrm>
+            <a:off x="594360" y="1828800"/>
+            <a:ext cx="201168" cy="201168"/>
           </a:xfrm>
           <a:prstGeom prst="ellipse">
             <a:avLst/>
@@ -4841,34 +5162,14 @@
       </p:sp>
       <p:sp>
         <p:nvSpPr>
-          <p:cNvPr id="6" name="Shape 4"/>
-          <p:cNvSpPr/>
-          <p:nvPr/>
-        </p:nvSpPr>
-        <p:spPr>
-          <a:xfrm>
-            <a:off x="11320272" y="3035808"/>
-            <a:ext cx="237744" cy="237744"/>
-          </a:xfrm>
-          <a:prstGeom prst="ellipse">
-            <a:avLst/>
-          </a:prstGeom>
-          <a:solidFill>
-            <a:srgbClr val="DC2626"/>
-          </a:solidFill>
-          <a:ln/>
-        </p:spPr>
-      </p:sp>
-      <p:sp>
-        <p:nvSpPr>
-          <p:cNvPr id="7" name="Text 5"/>
-          <p:cNvSpPr/>
-          <p:nvPr/>
-        </p:nvSpPr>
-        <p:spPr>
-          <a:xfrm>
-            <a:off x="594360" y="1234440"/>
-            <a:ext cx="8229600" cy="320040"/>
+          <p:cNvPr id="14" name="Text 12"/>
+          <p:cNvSpPr/>
+          <p:nvPr/>
+        </p:nvSpPr>
+        <p:spPr>
+          <a:xfrm>
+            <a:off x="1005840" y="1783080"/>
+            <a:ext cx="7772400" cy="365760"/>
           </a:xfrm>
           <a:prstGeom prst="rect">
             <a:avLst/>
@@ -4884,29 +5185,68 @@
               <a:buNone/>
             </a:pPr>
             <a:r>
-              <a:rPr lang="en-US" sz="1300" b="1" spc="200" kern="0" dirty="0">
-                <a:solidFill>
-                  <a:srgbClr val="5EEAD4"/>
-                </a:solidFill>
-                <a:latin typeface="Calibri" pitchFamily="34" charset="0"/>
-                <a:ea typeface="Calibri" pitchFamily="34" charset="-122"/>
-                <a:cs typeface="Calibri" pitchFamily="34" charset="-120"/>
-              </a:rPr>
-              <a:t>WHAT A PILOT IN KALAHANDI DELIVERS</a:t>
-            </a:r>
-            <a:endParaRPr lang="en-US" sz="1300" dirty="0"/>
-          </a:p>
-        </p:txBody>
-      </p:sp>
-      <p:sp>
-        <p:nvSpPr>
-          <p:cNvPr id="8" name="Shape 6"/>
-          <p:cNvSpPr/>
-          <p:nvPr/>
-        </p:nvSpPr>
-        <p:spPr>
-          <a:xfrm>
-            <a:off x="594360" y="1828800"/>
+              <a:rPr lang="en-US" sz="2000" b="1" dirty="0">
+                <a:solidFill>
+                  <a:srgbClr val="FFFFFF"/>
+                </a:solidFill>
+                <a:latin typeface="Cambria" pitchFamily="34" charset="0"/>
+                <a:ea typeface="Cambria" pitchFamily="34" charset="-122"/>
+                <a:cs typeface="Cambria" pitchFamily="34" charset="-120"/>
+              </a:rPr>
+              <a:t>Earlier response</a:t>
+            </a:r>
+            <a:endParaRPr lang="en-US" sz="2000" dirty="0"/>
+          </a:p>
+        </p:txBody>
+      </p:sp>
+      <p:sp>
+        <p:nvSpPr>
+          <p:cNvPr id="15" name="Text 13"/>
+          <p:cNvSpPr/>
+          <p:nvPr/>
+        </p:nvSpPr>
+        <p:spPr>
+          <a:xfrm>
+            <a:off x="1005840" y="2167128"/>
+            <a:ext cx="7589520" cy="457200"/>
+          </a:xfrm>
+          <a:prstGeom prst="rect">
+            <a:avLst/>
+          </a:prstGeom>
+          <a:noFill/>
+          <a:ln/>
+        </p:spPr>
+        <p:txBody>
+          <a:bodyPr wrap="square" lIns="0" tIns="0" rIns="0" bIns="0" rtlCol="0" anchor="ctr"/>
+          <a:lstStyle/>
+          <a:p>
+            <a:pPr indent="0" marL="0">
+              <a:buNone/>
+            </a:pPr>
+            <a:r>
+              <a:rPr lang="en-US" sz="1400" dirty="0">
+                <a:solidFill>
+                  <a:srgbClr val="CFE3EC"/>
+                </a:solidFill>
+                <a:latin typeface="Calibri" pitchFamily="34" charset="0"/>
+                <a:ea typeface="Calibri" pitchFamily="34" charset="-122"/>
+                <a:cs typeface="Calibri" pitchFamily="34" charset="-120"/>
+              </a:rPr>
+              <a:t>Outbreaks caught days sooner, while the case count is still small</a:t>
+            </a:r>
+            <a:endParaRPr lang="en-US" sz="1400" dirty="0"/>
+          </a:p>
+        </p:txBody>
+      </p:sp>
+      <p:sp>
+        <p:nvSpPr>
+          <p:cNvPr id="16" name="Shape 14"/>
+          <p:cNvSpPr/>
+          <p:nvPr/>
+        </p:nvSpPr>
+        <p:spPr>
+          <a:xfrm>
+            <a:off x="594360" y="2880360"/>
             <a:ext cx="201168" cy="201168"/>
           </a:xfrm>
           <a:prstGeom prst="ellipse">
@@ -4920,13 +5260,13 @@
       </p:sp>
       <p:sp>
         <p:nvSpPr>
-          <p:cNvPr id="9" name="Text 7"/>
-          <p:cNvSpPr/>
-          <p:nvPr/>
-        </p:nvSpPr>
-        <p:spPr>
-          <a:xfrm>
-            <a:off x="1005840" y="1783080"/>
+          <p:cNvPr id="17" name="Text 15"/>
+          <p:cNvSpPr/>
+          <p:nvPr/>
+        </p:nvSpPr>
+        <p:spPr>
+          <a:xfrm>
+            <a:off x="1005840" y="2834640"/>
             <a:ext cx="7772400" cy="365760"/>
           </a:xfrm>
           <a:prstGeom prst="rect">
@@ -4951,7 +5291,7 @@
                 <a:ea typeface="Cambria" pitchFamily="34" charset="-122"/>
                 <a:cs typeface="Cambria" pitchFamily="34" charset="-120"/>
               </a:rPr>
-              <a:t>Earlier response</a:t>
+              <a:t>Less waste</a:t>
             </a:r>
             <a:endParaRPr lang="en-US" sz="2000" dirty="0"/>
           </a:p>
@@ -4959,13 +5299,13 @@
       </p:sp>
       <p:sp>
         <p:nvSpPr>
-          <p:cNvPr id="10" name="Text 8"/>
-          <p:cNvSpPr/>
-          <p:nvPr/>
-        </p:nvSpPr>
-        <p:spPr>
-          <a:xfrm>
-            <a:off x="1005840" y="2167128"/>
+          <p:cNvPr id="18" name="Text 16"/>
+          <p:cNvSpPr/>
+          <p:nvPr/>
+        </p:nvSpPr>
+        <p:spPr>
+          <a:xfrm>
+            <a:off x="1005840" y="3218688"/>
             <a:ext cx="7589520" cy="457200"/>
           </a:xfrm>
           <a:prstGeom prst="rect">
@@ -4990,7 +5330,7 @@
                 <a:ea typeface="Calibri" pitchFamily="34" charset="-122"/>
                 <a:cs typeface="Calibri" pitchFamily="34" charset="-120"/>
               </a:rPr>
-              <a:t>Outbreaks caught days sooner, while the case count is still small</a:t>
+              <a:t>Medicines redistributed before they expire — lakhs saved each quarter</a:t>
             </a:r>
             <a:endParaRPr lang="en-US" sz="1400" dirty="0"/>
           </a:p>
@@ -4998,13 +5338,13 @@
       </p:sp>
       <p:sp>
         <p:nvSpPr>
-          <p:cNvPr id="11" name="Shape 9"/>
-          <p:cNvSpPr/>
-          <p:nvPr/>
-        </p:nvSpPr>
-        <p:spPr>
-          <a:xfrm>
-            <a:off x="594360" y="2880360"/>
+          <p:cNvPr id="19" name="Shape 17"/>
+          <p:cNvSpPr/>
+          <p:nvPr/>
+        </p:nvSpPr>
+        <p:spPr>
+          <a:xfrm>
+            <a:off x="594360" y="3931920"/>
             <a:ext cx="201168" cy="201168"/>
           </a:xfrm>
           <a:prstGeom prst="ellipse">
@@ -5018,13 +5358,13 @@
       </p:sp>
       <p:sp>
         <p:nvSpPr>
-          <p:cNvPr id="12" name="Text 10"/>
-          <p:cNvSpPr/>
-          <p:nvPr/>
-        </p:nvSpPr>
-        <p:spPr>
-          <a:xfrm>
-            <a:off x="1005840" y="2834640"/>
+          <p:cNvPr id="20" name="Text 18"/>
+          <p:cNvSpPr/>
+          <p:nvPr/>
+        </p:nvSpPr>
+        <p:spPr>
+          <a:xfrm>
+            <a:off x="1005840" y="3886200"/>
             <a:ext cx="7772400" cy="365760"/>
           </a:xfrm>
           <a:prstGeom prst="rect">
@@ -5049,7 +5389,7 @@
                 <a:ea typeface="Cambria" pitchFamily="34" charset="-122"/>
                 <a:cs typeface="Cambria" pitchFamily="34" charset="-120"/>
               </a:rPr>
-              <a:t>Less waste</a:t>
+              <a:t>A district in view</a:t>
             </a:r>
             <a:endParaRPr lang="en-US" sz="2000" dirty="0"/>
           </a:p>
@@ -5057,105 +5397,7 @@
       </p:sp>
       <p:sp>
         <p:nvSpPr>
-          <p:cNvPr id="13" name="Text 11"/>
-          <p:cNvSpPr/>
-          <p:nvPr/>
-        </p:nvSpPr>
-        <p:spPr>
-          <a:xfrm>
-            <a:off x="1005840" y="3218688"/>
-            <a:ext cx="7589520" cy="457200"/>
-          </a:xfrm>
-          <a:prstGeom prst="rect">
-            <a:avLst/>
-          </a:prstGeom>
-          <a:noFill/>
-          <a:ln/>
-        </p:spPr>
-        <p:txBody>
-          <a:bodyPr wrap="square" lIns="0" tIns="0" rIns="0" bIns="0" rtlCol="0" anchor="ctr"/>
-          <a:lstStyle/>
-          <a:p>
-            <a:pPr indent="0" marL="0">
-              <a:buNone/>
-            </a:pPr>
-            <a:r>
-              <a:rPr lang="en-US" sz="1400" dirty="0">
-                <a:solidFill>
-                  <a:srgbClr val="CFE3EC"/>
-                </a:solidFill>
-                <a:latin typeface="Calibri" pitchFamily="34" charset="0"/>
-                <a:ea typeface="Calibri" pitchFamily="34" charset="-122"/>
-                <a:cs typeface="Calibri" pitchFamily="34" charset="-120"/>
-              </a:rPr>
-              <a:t>Medicines redistributed before they expire — lakhs saved each quarter</a:t>
-            </a:r>
-            <a:endParaRPr lang="en-US" sz="1400" dirty="0"/>
-          </a:p>
-        </p:txBody>
-      </p:sp>
-      <p:sp>
-        <p:nvSpPr>
-          <p:cNvPr id="14" name="Shape 12"/>
-          <p:cNvSpPr/>
-          <p:nvPr/>
-        </p:nvSpPr>
-        <p:spPr>
-          <a:xfrm>
-            <a:off x="594360" y="3931920"/>
-            <a:ext cx="201168" cy="201168"/>
-          </a:xfrm>
-          <a:prstGeom prst="ellipse">
-            <a:avLst/>
-          </a:prstGeom>
-          <a:solidFill>
-            <a:srgbClr val="5EEAD4"/>
-          </a:solidFill>
-          <a:ln/>
-        </p:spPr>
-      </p:sp>
-      <p:sp>
-        <p:nvSpPr>
-          <p:cNvPr id="15" name="Text 13"/>
-          <p:cNvSpPr/>
-          <p:nvPr/>
-        </p:nvSpPr>
-        <p:spPr>
-          <a:xfrm>
-            <a:off x="1005840" y="3886200"/>
-            <a:ext cx="7772400" cy="365760"/>
-          </a:xfrm>
-          <a:prstGeom prst="rect">
-            <a:avLst/>
-          </a:prstGeom>
-          <a:noFill/>
-          <a:ln/>
-        </p:spPr>
-        <p:txBody>
-          <a:bodyPr wrap="square" lIns="0" tIns="0" rIns="0" bIns="0" rtlCol="0" anchor="ctr"/>
-          <a:lstStyle/>
-          <a:p>
-            <a:pPr indent="0" marL="0">
-              <a:buNone/>
-            </a:pPr>
-            <a:r>
-              <a:rPr lang="en-US" sz="2000" b="1" dirty="0">
-                <a:solidFill>
-                  <a:srgbClr val="FFFFFF"/>
-                </a:solidFill>
-                <a:latin typeface="Cambria" pitchFamily="34" charset="0"/>
-                <a:ea typeface="Cambria" pitchFamily="34" charset="-122"/>
-                <a:cs typeface="Cambria" pitchFamily="34" charset="-120"/>
-              </a:rPr>
-              <a:t>A district in view</a:t>
-            </a:r>
-            <a:endParaRPr lang="en-US" sz="2000" dirty="0"/>
-          </a:p>
-        </p:txBody>
-      </p:sp>
-      <p:sp>
-        <p:nvSpPr>
-          <p:cNvPr id="16" name="Text 14"/>
+          <p:cNvPr id="21" name="Text 19"/>
           <p:cNvSpPr/>
           <p:nvPr/>
         </p:nvSpPr>
@@ -5194,7 +5436,7 @@
       </p:sp>
       <p:sp>
         <p:nvSpPr>
-          <p:cNvPr id="17" name="Shape 15"/>
+          <p:cNvPr id="22" name="Shape 20"/>
           <p:cNvSpPr/>
           <p:nvPr/>
         </p:nvSpPr>
@@ -5217,7 +5459,7 @@
       </p:sp>
       <p:sp>
         <p:nvSpPr>
-          <p:cNvPr id="18" name="Text 16"/>
+          <p:cNvPr id="23" name="Text 21"/>
           <p:cNvSpPr/>
           <p:nvPr/>
         </p:nvSpPr>
@@ -5270,7 +5512,7 @@
       </p:sp>
       <p:sp>
         <p:nvSpPr>
-          <p:cNvPr id="19" name="Text 17"/>
+          <p:cNvPr id="24" name="Text 22"/>
           <p:cNvSpPr/>
           <p:nvPr/>
         </p:nvSpPr>
@@ -5351,7 +5593,7 @@
       </p:sp>
       <p:sp>
         <p:nvSpPr>
-          <p:cNvPr id="20" name="Text 18"/>
+          <p:cNvPr id="25" name="Text 23"/>
           <p:cNvSpPr/>
           <p:nvPr/>
         </p:nvSpPr>
@@ -5404,7 +5646,7 @@
       </p:sp>
       <p:sp>
         <p:nvSpPr>
-          <p:cNvPr id="21" name="Text 19"/>
+          <p:cNvPr id="26" name="Text 24"/>
           <p:cNvSpPr/>
           <p:nvPr/>
         </p:nvSpPr>
@@ -5443,7 +5685,7 @@
       </p:sp>
       <p:sp>
         <p:nvSpPr>
-          <p:cNvPr id="22" name="Text 20"/>
+          <p:cNvPr id="27" name="Text 25"/>
           <p:cNvSpPr/>
           <p:nvPr/>
         </p:nvSpPr>
@@ -5482,7 +5724,7 @@
       </p:sp>
       <p:sp>
         <p:nvSpPr>
-          <p:cNvPr id="23" name="Text 21"/>
+          <p:cNvPr id="28" name="Text 26"/>
           <p:cNvSpPr/>
           <p:nvPr/>
         </p:nvSpPr>
@@ -6314,10 +6556,10 @@
           <a:prstGeom prst="ellipse">
             <a:avLst/>
           </a:prstGeom>
-          <a:ln w="20320">
+          <a:ln w="22860">
             <a:solidFill>
               <a:srgbClr val="FF9933">
-                <a:alpha val="88000"/>
+                <a:alpha val="92000"/>
               </a:srgbClr>
             </a:solidFill>
             <a:prstDash val="solid"/>
@@ -6338,10 +6580,10 @@
           <a:prstGeom prst="ellipse">
             <a:avLst/>
           </a:prstGeom>
-          <a:ln w="20320">
+          <a:ln w="22860">
             <a:solidFill>
               <a:srgbClr val="FFFFFF">
-                <a:alpha val="88000"/>
+                <a:alpha val="92000"/>
               </a:srgbClr>
             </a:solidFill>
             <a:prstDash val="solid"/>
@@ -6362,10 +6604,10 @@
           <a:prstGeom prst="ellipse">
             <a:avLst/>
           </a:prstGeom>
-          <a:ln w="20320">
+          <a:ln w="22860">
             <a:solidFill>
               <a:srgbClr val="17A34A">
-                <a:alpha val="88000"/>
+                <a:alpha val="92000"/>
               </a:srgbClr>
             </a:solidFill>
             <a:prstDash val="solid"/>
@@ -6380,16 +6622,19 @@
         </p:nvSpPr>
         <p:spPr>
           <a:xfrm>
-            <a:off x="10076688" y="3493008"/>
-            <a:ext cx="146304" cy="146304"/>
-          </a:xfrm>
-          <a:prstGeom prst="ellipse">
-            <a:avLst/>
-          </a:prstGeom>
-          <a:solidFill>
-            <a:srgbClr val="5EEAD4"/>
-          </a:solidFill>
-          <a:ln/>
+            <a:off x="8238744" y="3566160"/>
+            <a:ext cx="1042416" cy="0"/>
+          </a:xfrm>
+          <a:prstGeom prst="line">
+            <a:avLst/>
+          </a:prstGeom>
+          <a:noFill/>
+          <a:ln w="28575">
+            <a:solidFill>
+              <a:srgbClr val="5EEAD4"/>
+            </a:solidFill>
+            <a:prstDash val="solid"/>
+          </a:ln>
         </p:spPr>
       </p:sp>
       <p:sp>
@@ -6400,21 +6645,139 @@
         </p:nvSpPr>
         <p:spPr>
           <a:xfrm>
-            <a:off x="11228832" y="2852928"/>
-            <a:ext cx="237744" cy="237744"/>
-          </a:xfrm>
-          <a:prstGeom prst="ellipse">
-            <a:avLst/>
-          </a:prstGeom>
-          <a:solidFill>
-            <a:srgbClr val="DC2626"/>
-          </a:solidFill>
-          <a:ln/>
-        </p:spPr>
-      </p:sp>
-      <p:sp>
-        <p:nvSpPr>
-          <p:cNvPr id="7" name="Text 5"/>
+            <a:off x="9281160" y="3566160"/>
+            <a:ext cx="304038" cy="0"/>
+          </a:xfrm>
+          <a:prstGeom prst="line">
+            <a:avLst/>
+          </a:prstGeom>
+          <a:noFill/>
+          <a:ln w="28575">
+            <a:solidFill>
+              <a:srgbClr val="5EEAD4"/>
+            </a:solidFill>
+            <a:prstDash val="solid"/>
+          </a:ln>
+        </p:spPr>
+      </p:sp>
+      <p:sp>
+        <p:nvSpPr>
+          <p:cNvPr id="7" name="Shape 5"/>
+          <p:cNvSpPr/>
+          <p:nvPr/>
+        </p:nvSpPr>
+        <p:spPr>
+          <a:xfrm flipV="1">
+            <a:off x="9585198" y="2610612"/>
+            <a:ext cx="304038" cy="955548"/>
+          </a:xfrm>
+          <a:prstGeom prst="line">
+            <a:avLst/>
+          </a:prstGeom>
+          <a:noFill/>
+          <a:ln w="28575">
+            <a:solidFill>
+              <a:srgbClr val="5EEAD4"/>
+            </a:solidFill>
+            <a:prstDash val="solid"/>
+          </a:ln>
+        </p:spPr>
+      </p:sp>
+      <p:sp>
+        <p:nvSpPr>
+          <p:cNvPr id="8" name="Shape 6"/>
+          <p:cNvSpPr/>
+          <p:nvPr/>
+        </p:nvSpPr>
+        <p:spPr>
+          <a:xfrm>
+            <a:off x="9889236" y="2610612"/>
+            <a:ext cx="347472" cy="1911096"/>
+          </a:xfrm>
+          <a:prstGeom prst="line">
+            <a:avLst/>
+          </a:prstGeom>
+          <a:noFill/>
+          <a:ln w="28575">
+            <a:solidFill>
+              <a:srgbClr val="5EEAD4"/>
+            </a:solidFill>
+            <a:prstDash val="solid"/>
+          </a:ln>
+        </p:spPr>
+      </p:sp>
+      <p:sp>
+        <p:nvSpPr>
+          <p:cNvPr id="9" name="Shape 7"/>
+          <p:cNvSpPr/>
+          <p:nvPr/>
+        </p:nvSpPr>
+        <p:spPr>
+          <a:xfrm flipV="1">
+            <a:off x="10236708" y="3044952"/>
+            <a:ext cx="304038" cy="1476756"/>
+          </a:xfrm>
+          <a:prstGeom prst="line">
+            <a:avLst/>
+          </a:prstGeom>
+          <a:noFill/>
+          <a:ln w="28575">
+            <a:solidFill>
+              <a:srgbClr val="5EEAD4"/>
+            </a:solidFill>
+            <a:prstDash val="solid"/>
+          </a:ln>
+        </p:spPr>
+      </p:sp>
+      <p:sp>
+        <p:nvSpPr>
+          <p:cNvPr id="10" name="Shape 8"/>
+          <p:cNvSpPr/>
+          <p:nvPr/>
+        </p:nvSpPr>
+        <p:spPr>
+          <a:xfrm>
+            <a:off x="10540746" y="3044952"/>
+            <a:ext cx="260604" cy="521208"/>
+          </a:xfrm>
+          <a:prstGeom prst="line">
+            <a:avLst/>
+          </a:prstGeom>
+          <a:noFill/>
+          <a:ln w="28575">
+            <a:solidFill>
+              <a:srgbClr val="5EEAD4"/>
+            </a:solidFill>
+            <a:prstDash val="solid"/>
+          </a:ln>
+        </p:spPr>
+      </p:sp>
+      <p:sp>
+        <p:nvSpPr>
+          <p:cNvPr id="11" name="Shape 9"/>
+          <p:cNvSpPr/>
+          <p:nvPr/>
+        </p:nvSpPr>
+        <p:spPr>
+          <a:xfrm>
+            <a:off x="10801350" y="3566160"/>
+            <a:ext cx="1259586" cy="0"/>
+          </a:xfrm>
+          <a:prstGeom prst="line">
+            <a:avLst/>
+          </a:prstGeom>
+          <a:noFill/>
+          <a:ln w="28575">
+            <a:solidFill>
+              <a:srgbClr val="5EEAD4"/>
+            </a:solidFill>
+            <a:prstDash val="solid"/>
+          </a:ln>
+        </p:spPr>
+      </p:sp>
+      <p:sp>
+        <p:nvSpPr>
+          <p:cNvPr id="12" name="Text 10"/>
           <p:cNvSpPr/>
           <p:nvPr/>
         </p:nvSpPr>
@@ -6453,7 +6816,7 @@
       </p:sp>
       <p:sp>
         <p:nvSpPr>
-          <p:cNvPr id="8" name="Text 6"/>
+          <p:cNvPr id="13" name="Text 11"/>
           <p:cNvSpPr/>
           <p:nvPr/>
         </p:nvSpPr>
@@ -6495,7 +6858,7 @@
       </p:sp>
       <p:sp>
         <p:nvSpPr>
-          <p:cNvPr id="9" name="Text 7"/>
+          <p:cNvPr id="14" name="Text 12"/>
           <p:cNvSpPr/>
           <p:nvPr/>
         </p:nvSpPr>
@@ -6537,7 +6900,7 @@
       </p:sp>
       <p:sp>
         <p:nvSpPr>
-          <p:cNvPr id="10" name="Text 8"/>
+          <p:cNvPr id="15" name="Text 13"/>
           <p:cNvSpPr/>
           <p:nvPr/>
         </p:nvSpPr>
@@ -6576,7 +6939,7 @@
       </p:sp>
       <p:sp>
         <p:nvSpPr>
-          <p:cNvPr id="11" name="Text 9"/>
+          <p:cNvPr id="16" name="Text 14"/>
           <p:cNvSpPr/>
           <p:nvPr/>
         </p:nvSpPr>
@@ -6615,7 +6978,7 @@
       </p:sp>
       <p:sp>
         <p:nvSpPr>
-          <p:cNvPr id="12" name="Text 10"/>
+          <p:cNvPr id="17" name="Text 15"/>
           <p:cNvSpPr/>
           <p:nvPr/>
         </p:nvSpPr>

</xml_diff>